<commit_message>
HB-FY24 final: label the bracketed interval as the 95% confidence interval of the difference
The interval after a policy − Human baseline difference was labelled
'[95% 구간]' right after 'Human baseline', which could be read as an
interval of the Human baseline score. Comparison document table 3 now
shows the mean difference and its 95% confidence interval on separate
rows; thesis table 7-6 and appendix F-3, the 15-page summary table 6,
the results summary and slide 15 name it as the interval of the
difference. No values changed.
</commit_message>
<xml_diff>
--- a/human_baseline_final_20261019/02_학위논문_및_발표/학위논문_심사발표_조종선_개정.pptx
+++ b/human_baseline_final_20261019/02_학위논문_및_발표/학위논문_심사발표_조종선_개정.pptx
@@ -6663,6 +6663,10 @@
             <a:prstDash val="solid"/>
           </a:ln>
         </p:spPr>
+        <p:txBody>
+          <a:bodyPr/>
+          <a:p/>
+        </p:txBody>
       </p:sp>
       <p:sp>
         <p:nvSpPr>
@@ -6910,6 +6914,10 @@
             <a:prstDash val="solid"/>
           </a:ln>
         </p:spPr>
+        <p:txBody>
+          <a:bodyPr/>
+          <a:p/>
+        </p:txBody>
       </p:sp>
       <p:sp>
         <p:nvSpPr>
@@ -7121,6 +7129,10 @@
             <a:prstDash val="solid"/>
           </a:ln>
         </p:spPr>
+        <p:txBody>
+          <a:bodyPr/>
+          <a:p/>
+        </p:txBody>
       </p:sp>
       <p:sp>
         <p:nvSpPr>
@@ -7332,6 +7344,10 @@
             <a:prstDash val="solid"/>
           </a:ln>
         </p:spPr>
+        <p:txBody>
+          <a:bodyPr/>
+          <a:p/>
+        </p:txBody>
       </p:sp>
       <p:sp>
         <p:nvSpPr>
@@ -9499,7 +9515,7 @@
                             <a:srgbClr val="3A4550"/>
                           </a:solidFill>
                         </a:rPr>
-                        <a:t>Human baseline 대비 [95% 구간]</a:t>
+                        <a:t>HB 대비 차이 [95% 신뢰구간]</a:t>
                       </a:r>
                       <a:endParaRPr lang="en-US" sz="1250" dirty="0"/>
                     </a:p>
@@ -12965,6 +12981,10 @@
             <a:prstDash val="solid"/>
           </a:ln>
         </p:spPr>
+        <p:txBody>
+          <a:bodyPr/>
+          <a:p/>
+        </p:txBody>
       </p:sp>
       <p:sp>
         <p:nvSpPr>
@@ -13120,6 +13140,10 @@
             <a:prstDash val="solid"/>
           </a:ln>
         </p:spPr>
+        <p:txBody>
+          <a:bodyPr/>
+          <a:p/>
+        </p:txBody>
       </p:sp>
       <p:sp>
         <p:nvSpPr>
@@ -13839,6 +13863,10 @@
             <a:prstDash val="solid"/>
           </a:ln>
         </p:spPr>
+        <p:txBody>
+          <a:bodyPr/>
+          <a:p/>
+        </p:txBody>
       </p:sp>
       <p:sp>
         <p:nvSpPr>
@@ -15115,6 +15143,10 @@
             <a:prstDash val="solid"/>
           </a:ln>
         </p:spPr>
+        <p:txBody>
+          <a:bodyPr/>
+          <a:p/>
+        </p:txBody>
       </p:sp>
       <p:sp>
         <p:nvSpPr>
@@ -15282,6 +15314,10 @@
             <a:prstDash val="solid"/>
           </a:ln>
         </p:spPr>
+        <p:txBody>
+          <a:bodyPr/>
+          <a:p/>
+        </p:txBody>
       </p:sp>
       <p:sp>
         <p:nvSpPr>
@@ -17095,6 +17131,10 @@
             <a:prstDash val="solid"/>
           </a:ln>
         </p:spPr>
+        <p:txBody>
+          <a:bodyPr/>
+          <a:p/>
+        </p:txBody>
       </p:sp>
       <p:sp>
         <p:nvSpPr>

</xml_diff>

<commit_message>
records: revise wording in human baseline notes and deck
</commit_message>
<xml_diff>
--- a/human_baseline_final_20261019/02_학위논문_및_발표/학위논문_심사발표_조종선_개정.pptx
+++ b/human_baseline_final_20261019/02_학위논문_및_발표/학위논문_심사발표_조종선_개정.pptx
@@ -5475,7 +5475,7 @@
       </p:sp>
       <p:pic>
         <p:nvPicPr>
-          <p:cNvPr id="4" name="Image 0" descr="/tmp/claude-0/-home-claude/feeeb36e-29bc-50c9-9e7f-9bc641c3f387/scratchpad/thesis/figures/fig_usability.png">    </p:cNvPr>
+          <p:cNvPr id="4" name="Image 0" descr="fig_usability.png">    </p:cNvPr>
           <p:cNvPicPr>
             <a:picLocks noChangeAspect="1"/>
           </p:cNvPicPr>
@@ -17085,7 +17085,7 @@
       </p:sp>
       <p:pic>
         <p:nvPicPr>
-          <p:cNvPr id="4" name="Image 0" descr="/tmp/claude-0/-home-claude/feeeb36e-29bc-50c9-9e7f-9bc641c3f387/scratchpad/thesis/figures/fig_arch.png">    </p:cNvPr>
+          <p:cNvPr id="4" name="Image 0" descr="fig_arch.png">    </p:cNvPr>
           <p:cNvPicPr>
             <a:picLocks noChangeAspect="1"/>
           </p:cNvPicPr>

</xml_diff>